<commit_message>
Tien weken in plaats van twaalf, en een respectvollere toon op de cover
De looptijd van de lopende samenwerking stond op twaalf weken terwijl we
tien weken bezig zijn. Gecorrigeerd in het pilotvoorstel, het
evaluatiedeck en de interactieve pagina. De pilotduur van twaalf weken
blijft staan, dat is een andere periode.

De cover gaf te veel het idee dat hun eigen werk tekortschoot. De titel
erkent nu dat hun propositie werkt en biedt de rest van het land aan.

Co-Authored-By: Claude Opus 5 <noreply@anthropic.com>
Claude-Session: https://claude.ai/code/session_0141FN3f3hHkYQHTyvTJJGrw
</commit_message>
<xml_diff>
--- a/output/LINK. pilotvoorstel OK Creative Agency.pptx
+++ b/output/LINK. pilotvoorstel OK Creative Agency.pptx
@@ -2645,7 +2645,7 @@
                 <a:ea typeface="Arial" pitchFamily="34" charset="-122"/>
                 <a:cs typeface="Arial" pitchFamily="34" charset="-120"/>
               </a:rPr>
-              <a:t>Jullie makelaarsverhaal, nu </a:t>
+              <a:t>Jullie propositie werkt. Nu </a:t>
             </a:r>
             <a:pPr algn="l" indent="0" marL="0">
               <a:lnSpc>
@@ -2662,7 +2662,7 @@
                 <a:ea typeface="Georgia" pitchFamily="34" charset="-122"/>
                 <a:cs typeface="Georgia" pitchFamily="34" charset="-120"/>
               </a:rPr>
-              <a:t>op schaal</a:t>
+              <a:t>heel Nederland</a:t>
             </a:r>
             <a:pPr algn="l" indent="0" marL="0">
               <a:lnSpc>
@@ -6488,7 +6488,7 @@
                 <a:ea typeface="Arial" pitchFamily="34" charset="-122"/>
                 <a:cs typeface="Arial" pitchFamily="34" charset="-120"/>
               </a:rPr>
-              <a:t>Sinds augustus bellen wij voor jullie in de zakelijke dienstverlening. In die twaalf weken hebben we 452 directeuren en marketingverantwoordelijken persoonlijk gesproken en veertien afspraken en overdrachten geleverd. We kennen jullie verhaal inmiddels van binnenuit.</a:t>
+              <a:t>Sinds augustus bellen wij voor jullie in de zakelijke dienstverlening. In die tien weken hebben we 452 directeuren en marketingverantwoordelijken persoonlijk gesproken en veertien afspraken en overdrachten geleverd. We kennen jullie verhaal inmiddels van binnenuit.</a:t>
             </a:r>
             <a:endParaRPr lang="en-US" sz="1350" dirty="0"/>
           </a:p>
@@ -7970,7 +7970,7 @@
                 <a:ea typeface="Arial" pitchFamily="34" charset="-122"/>
                 <a:cs typeface="Arial" pitchFamily="34" charset="-120"/>
               </a:rPr>
-              <a:t>Twintig kantoren in één hoek. </a:t>
+              <a:t>Twintig kantoren benaderd. </a:t>
             </a:r>
             <a:pPr algn="l" indent="0" marL="0">
               <a:lnSpc>
@@ -8004,7 +8004,7 @@
                 <a:ea typeface="Arial" pitchFamily="34" charset="-122"/>
                 <a:cs typeface="Arial" pitchFamily="34" charset="-120"/>
               </a:rPr>
-              <a:t> in het land.</a:t>
+              <a:t> te gaan.</a:t>
             </a:r>
             <a:endParaRPr lang="en-US" sz="3200" dirty="0"/>
           </a:p>
@@ -8640,7 +8640,7 @@
                 <a:ea typeface="Georgia" pitchFamily="34" charset="-122"/>
                 <a:cs typeface="Georgia" pitchFamily="34" charset="-120"/>
               </a:rPr>
-              <a:t>capaciteit</a:t>
+              <a:t>uren</a:t>
             </a:r>
             <a:pPr algn="l" indent="0" marL="0">
               <a:lnSpc>
@@ -8657,7 +8657,7 @@
                 <a:ea typeface="Arial" pitchFamily="34" charset="-122"/>
                 <a:cs typeface="Arial" pitchFamily="34" charset="-120"/>
               </a:rPr>
-              <a:t> ontbreekt.</a:t>
+              <a:t> ontbreken.</a:t>
             </a:r>
             <a:endParaRPr lang="en-US" sz="3200" dirty="0"/>
           </a:p>

</xml_diff>